<commit_message>
Update Label Encoding presentation file
</commit_message>
<xml_diff>
--- a/My Note and Practice/Text to Numerical Data Conversion/Categorical(Text to Numeric) data conversion-CTtN/Ordinal Data/CTOtN1. Label Encoding/Label Encoding.pptx
+++ b/My Note and Practice/Text to Numerical Data Conversion/Categorical(Text to Numeric) data conversion-CTtN/Ordinal Data/CTOtN1. Label Encoding/Label Encoding.pptx
@@ -5,15 +5,15 @@
     <p:sldMasterId id="2147483648" r:id="rId1"/>
   </p:sldMasterIdLst>
   <p:sldIdLst>
-    <p:sldId id="309" r:id="rId2"/>
-    <p:sldId id="310" r:id="rId3"/>
-    <p:sldId id="311" r:id="rId4"/>
-    <p:sldId id="312" r:id="rId5"/>
-    <p:sldId id="313" r:id="rId6"/>
-    <p:sldId id="314" r:id="rId7"/>
-    <p:sldId id="315" r:id="rId8"/>
-    <p:sldId id="316" r:id="rId9"/>
-    <p:sldId id="317" r:id="rId10"/>
+    <p:sldId id="317" r:id="rId2"/>
+    <p:sldId id="309" r:id="rId3"/>
+    <p:sldId id="310" r:id="rId4"/>
+    <p:sldId id="311" r:id="rId5"/>
+    <p:sldId id="312" r:id="rId6"/>
+    <p:sldId id="313" r:id="rId7"/>
+    <p:sldId id="314" r:id="rId8"/>
+    <p:sldId id="315" r:id="rId9"/>
+    <p:sldId id="316" r:id="rId10"/>
   </p:sldIdLst>
   <p:sldSz cx="12192000" cy="6858000"/>
   <p:notesSz cx="6858000" cy="9144000"/>
@@ -278,7 +278,7 @@
           <a:p>
             <a:fld id="{D6171EE1-2692-479A-A6A6-950CA86052A8}" type="datetimeFigureOut">
               <a:rPr lang="en-US" smtClean="0"/>
-              <a:t>11/8/2025</a:t>
+              <a:t>11/19/2025</a:t>
             </a:fld>
             <a:endParaRPr lang="en-US"/>
           </a:p>
@@ -476,7 +476,7 @@
           <a:p>
             <a:fld id="{D6171EE1-2692-479A-A6A6-950CA86052A8}" type="datetimeFigureOut">
               <a:rPr lang="en-US" smtClean="0"/>
-              <a:t>11/8/2025</a:t>
+              <a:t>11/19/2025</a:t>
             </a:fld>
             <a:endParaRPr lang="en-US"/>
           </a:p>
@@ -684,7 +684,7 @@
           <a:p>
             <a:fld id="{D6171EE1-2692-479A-A6A6-950CA86052A8}" type="datetimeFigureOut">
               <a:rPr lang="en-US" smtClean="0"/>
-              <a:t>11/8/2025</a:t>
+              <a:t>11/19/2025</a:t>
             </a:fld>
             <a:endParaRPr lang="en-US"/>
           </a:p>
@@ -882,7 +882,7 @@
           <a:p>
             <a:fld id="{D6171EE1-2692-479A-A6A6-950CA86052A8}" type="datetimeFigureOut">
               <a:rPr lang="en-US" smtClean="0"/>
-              <a:t>11/8/2025</a:t>
+              <a:t>11/19/2025</a:t>
             </a:fld>
             <a:endParaRPr lang="en-US"/>
           </a:p>
@@ -1157,7 +1157,7 @@
           <a:p>
             <a:fld id="{D6171EE1-2692-479A-A6A6-950CA86052A8}" type="datetimeFigureOut">
               <a:rPr lang="en-US" smtClean="0"/>
-              <a:t>11/8/2025</a:t>
+              <a:t>11/19/2025</a:t>
             </a:fld>
             <a:endParaRPr lang="en-US"/>
           </a:p>
@@ -1422,7 +1422,7 @@
           <a:p>
             <a:fld id="{D6171EE1-2692-479A-A6A6-950CA86052A8}" type="datetimeFigureOut">
               <a:rPr lang="en-US" smtClean="0"/>
-              <a:t>11/8/2025</a:t>
+              <a:t>11/19/2025</a:t>
             </a:fld>
             <a:endParaRPr lang="en-US"/>
           </a:p>
@@ -1834,7 +1834,7 @@
           <a:p>
             <a:fld id="{D6171EE1-2692-479A-A6A6-950CA86052A8}" type="datetimeFigureOut">
               <a:rPr lang="en-US" smtClean="0"/>
-              <a:t>11/8/2025</a:t>
+              <a:t>11/19/2025</a:t>
             </a:fld>
             <a:endParaRPr lang="en-US"/>
           </a:p>
@@ -1975,7 +1975,7 @@
           <a:p>
             <a:fld id="{D6171EE1-2692-479A-A6A6-950CA86052A8}" type="datetimeFigureOut">
               <a:rPr lang="en-US" smtClean="0"/>
-              <a:t>11/8/2025</a:t>
+              <a:t>11/19/2025</a:t>
             </a:fld>
             <a:endParaRPr lang="en-US"/>
           </a:p>
@@ -2088,7 +2088,7 @@
           <a:p>
             <a:fld id="{D6171EE1-2692-479A-A6A6-950CA86052A8}" type="datetimeFigureOut">
               <a:rPr lang="en-US" smtClean="0"/>
-              <a:t>11/8/2025</a:t>
+              <a:t>11/19/2025</a:t>
             </a:fld>
             <a:endParaRPr lang="en-US"/>
           </a:p>
@@ -2399,7 +2399,7 @@
           <a:p>
             <a:fld id="{D6171EE1-2692-479A-A6A6-950CA86052A8}" type="datetimeFigureOut">
               <a:rPr lang="en-US" smtClean="0"/>
-              <a:t>11/8/2025</a:t>
+              <a:t>11/19/2025</a:t>
             </a:fld>
             <a:endParaRPr lang="en-US"/>
           </a:p>
@@ -2687,7 +2687,7 @@
           <a:p>
             <a:fld id="{D6171EE1-2692-479A-A6A6-950CA86052A8}" type="datetimeFigureOut">
               <a:rPr lang="en-US" smtClean="0"/>
-              <a:t>11/8/2025</a:t>
+              <a:t>11/19/2025</a:t>
             </a:fld>
             <a:endParaRPr lang="en-US"/>
           </a:p>
@@ -2928,7 +2928,7 @@
           <a:p>
             <a:fld id="{D6171EE1-2692-479A-A6A6-950CA86052A8}" type="datetimeFigureOut">
               <a:rPr lang="en-US" smtClean="0"/>
-              <a:t>11/8/2025</a:t>
+              <a:t>11/19/2025</a:t>
             </a:fld>
             <a:endParaRPr lang="en-US"/>
           </a:p>
@@ -3333,6 +3333,102 @@
   <p:cSld>
     <p:spTree>
       <p:nvGrpSpPr>
+        <p:cNvPr id="1" name=""/>
+        <p:cNvGrpSpPr/>
+        <p:nvPr/>
+      </p:nvGrpSpPr>
+      <p:grpSpPr>
+        <a:xfrm>
+          <a:off x="0" y="0"/>
+          <a:ext cx="0" cy="0"/>
+          <a:chOff x="0" y="0"/>
+          <a:chExt cx="0" cy="0"/>
+        </a:xfrm>
+      </p:grpSpPr>
+      <p:sp>
+        <p:nvSpPr>
+          <p:cNvPr id="2" name="Title 1">
+            <a:extLst>
+              <a:ext uri="{FF2B5EF4-FFF2-40B4-BE49-F238E27FC236}">
+                <a16:creationId xmlns:a16="http://schemas.microsoft.com/office/drawing/2014/main" id="{70FA9CB0-A2FE-78DF-9B5B-4C5BD9E0655A}"/>
+              </a:ext>
+            </a:extLst>
+          </p:cNvPr>
+          <p:cNvSpPr>
+            <a:spLocks noGrp="1"/>
+          </p:cNvSpPr>
+          <p:nvPr>
+            <p:ph type="ctrTitle"/>
+          </p:nvPr>
+        </p:nvSpPr>
+        <p:spPr/>
+        <p:txBody>
+          <a:bodyPr>
+            <a:noAutofit/>
+          </a:bodyPr>
+          <a:lstStyle/>
+          <a:p>
+            <a:r>
+              <a:rPr lang="en-US" sz="7000" dirty="0">
+                <a:latin typeface="Bebas Neue" panose="020B0606020202050201" pitchFamily="34" charset="0"/>
+              </a:rPr>
+              <a:t>Label Encoding in Machine Learning</a:t>
+            </a:r>
+          </a:p>
+        </p:txBody>
+      </p:sp>
+      <p:sp>
+        <p:nvSpPr>
+          <p:cNvPr id="3" name="Subtitle 2">
+            <a:extLst>
+              <a:ext uri="{FF2B5EF4-FFF2-40B4-BE49-F238E27FC236}">
+                <a16:creationId xmlns:a16="http://schemas.microsoft.com/office/drawing/2014/main" id="{C46EECFB-FAC7-E3D7-0311-EDE7CDAFCD07}"/>
+              </a:ext>
+            </a:extLst>
+          </p:cNvPr>
+          <p:cNvSpPr>
+            <a:spLocks noGrp="1"/>
+          </p:cNvSpPr>
+          <p:nvPr>
+            <p:ph type="subTitle" idx="1"/>
+          </p:nvPr>
+        </p:nvSpPr>
+        <p:spPr/>
+        <p:txBody>
+          <a:bodyPr>
+            <a:normAutofit/>
+          </a:bodyPr>
+          <a:lstStyle/>
+          <a:p>
+            <a:r>
+              <a:rPr lang="en-US" sz="3200" dirty="0">
+                <a:latin typeface="Open Sans" pitchFamily="2" charset="0"/>
+                <a:ea typeface="Open Sans" pitchFamily="2" charset="0"/>
+                <a:cs typeface="Open Sans" pitchFamily="2" charset="0"/>
+              </a:rPr>
+              <a:t>A Simple Technique to Convert Categories into Numbers</a:t>
+            </a:r>
+          </a:p>
+        </p:txBody>
+      </p:sp>
+    </p:spTree>
+    <p:extLst>
+      <p:ext uri="{BB962C8B-B14F-4D97-AF65-F5344CB8AC3E}">
+        <p14:creationId xmlns:p14="http://schemas.microsoft.com/office/powerpoint/2010/main" val="923816893"/>
+      </p:ext>
+    </p:extLst>
+  </p:cSld>
+  <p:clrMapOvr>
+    <a:masterClrMapping/>
+  </p:clrMapOvr>
+</p:sld>
+</file>
+
+<file path=ppt/slides/slide2.xml><?xml version="1.0" encoding="utf-8"?>
+<p:sld xmlns:a="http://schemas.openxmlformats.org/drawingml/2006/main" xmlns:r="http://schemas.openxmlformats.org/officeDocument/2006/relationships" xmlns:p="http://schemas.openxmlformats.org/presentationml/2006/main">
+  <p:cSld>
+    <p:spTree>
+      <p:nvGrpSpPr>
         <p:cNvPr id="1" name="">
           <a:extLst>
             <a:ext uri="{FF2B5EF4-FFF2-40B4-BE49-F238E27FC236}">
@@ -3532,7 +3628,7 @@
 </p:sld>
 </file>
 
-<file path=ppt/slides/slide2.xml><?xml version="1.0" encoding="utf-8"?>
+<file path=ppt/slides/slide3.xml><?xml version="1.0" encoding="utf-8"?>
 <p:sld xmlns:a="http://schemas.openxmlformats.org/drawingml/2006/main" xmlns:r="http://schemas.openxmlformats.org/officeDocument/2006/relationships" xmlns:p="http://schemas.openxmlformats.org/presentationml/2006/main">
   <p:cSld>
     <p:spTree>
@@ -5122,7 +5218,7 @@
 </p:sld>
 </file>
 
-<file path=ppt/slides/slide3.xml><?xml version="1.0" encoding="utf-8"?>
+<file path=ppt/slides/slide4.xml><?xml version="1.0" encoding="utf-8"?>
 <p:sld xmlns:a="http://schemas.openxmlformats.org/drawingml/2006/main" xmlns:r="http://schemas.openxmlformats.org/officeDocument/2006/relationships" xmlns:p="http://schemas.openxmlformats.org/presentationml/2006/main">
   <p:cSld>
     <p:spTree>
@@ -7260,7 +7356,7 @@
 </p:sld>
 </file>
 
-<file path=ppt/slides/slide4.xml><?xml version="1.0" encoding="utf-8"?>
+<file path=ppt/slides/slide5.xml><?xml version="1.0" encoding="utf-8"?>
 <p:sld xmlns:a="http://schemas.openxmlformats.org/drawingml/2006/main" xmlns:r="http://schemas.openxmlformats.org/officeDocument/2006/relationships" xmlns:p="http://schemas.openxmlformats.org/presentationml/2006/main">
   <p:cSld>
     <p:spTree>
@@ -8438,7 +8534,7 @@
 </p:sld>
 </file>
 
-<file path=ppt/slides/slide5.xml><?xml version="1.0" encoding="utf-8"?>
+<file path=ppt/slides/slide6.xml><?xml version="1.0" encoding="utf-8"?>
 <p:sld xmlns:a="http://schemas.openxmlformats.org/drawingml/2006/main" xmlns:r="http://schemas.openxmlformats.org/officeDocument/2006/relationships" xmlns:p="http://schemas.openxmlformats.org/presentationml/2006/main">
   <p:cSld>
     <p:spTree>
@@ -8609,39 +8705,7 @@
                 <a:ea typeface="Open Sans" pitchFamily="2" charset="0"/>
                 <a:cs typeface="Open Sans" pitchFamily="2" charset="0"/>
               </a:rPr>
-              <a:t>Using </a:t>
-            </a:r>
-            <a:r>
-              <a:rPr lang="en-US" sz="2400" dirty="0" err="1">
-                <a:latin typeface="Open Sans" pitchFamily="2" charset="0"/>
-                <a:ea typeface="Open Sans" pitchFamily="2" charset="0"/>
-                <a:cs typeface="Open Sans" pitchFamily="2" charset="0"/>
-              </a:rPr>
-              <a:t>LabelEncoder</a:t>
-            </a:r>
-            <a:r>
-              <a:rPr lang="en-US" sz="2400" dirty="0">
-                <a:latin typeface="Open Sans" pitchFamily="2" charset="0"/>
-                <a:ea typeface="Open Sans" pitchFamily="2" charset="0"/>
-                <a:cs typeface="Open Sans" pitchFamily="2" charset="0"/>
-              </a:rPr>
-              <a:t>. For this we have to use </a:t>
-            </a:r>
-            <a:r>
-              <a:rPr lang="en-US" sz="2400" dirty="0" err="1">
-                <a:latin typeface="Open Sans" pitchFamily="2" charset="0"/>
-                <a:ea typeface="Open Sans" pitchFamily="2" charset="0"/>
-                <a:cs typeface="Open Sans" pitchFamily="2" charset="0"/>
-              </a:rPr>
-              <a:t>OrdinalEncoder</a:t>
-            </a:r>
-            <a:r>
-              <a:rPr lang="en-US" sz="2400" dirty="0">
-                <a:latin typeface="Open Sans" pitchFamily="2" charset="0"/>
-                <a:ea typeface="Open Sans" pitchFamily="2" charset="0"/>
-                <a:cs typeface="Open Sans" pitchFamily="2" charset="0"/>
-              </a:rPr>
-              <a:t>.</a:t>
+              <a:t>Using Label Encoder. For this we have to use Ordinal Encoder.</a:t>
             </a:r>
           </a:p>
         </p:txBody>
@@ -8946,138 +9010,6 @@
 </p:sld>
 </file>
 
-<file path=ppt/slides/slide6.xml><?xml version="1.0" encoding="utf-8"?>
-<p:sld xmlns:a="http://schemas.openxmlformats.org/drawingml/2006/main" xmlns:r="http://schemas.openxmlformats.org/officeDocument/2006/relationships" xmlns:p="http://schemas.openxmlformats.org/presentationml/2006/main">
-  <p:cSld>
-    <p:spTree>
-      <p:nvGrpSpPr>
-        <p:cNvPr id="1" name="">
-          <a:extLst>
-            <a:ext uri="{FF2B5EF4-FFF2-40B4-BE49-F238E27FC236}">
-              <a16:creationId xmlns:a16="http://schemas.microsoft.com/office/drawing/2014/main" id="{8CA822CF-61E7-D4A4-E048-D296A45421F7}"/>
-            </a:ext>
-          </a:extLst>
-        </p:cNvPr>
-        <p:cNvGrpSpPr/>
-        <p:nvPr/>
-      </p:nvGrpSpPr>
-      <p:grpSpPr>
-        <a:xfrm>
-          <a:off x="0" y="0"/>
-          <a:ext cx="0" cy="0"/>
-          <a:chOff x="0" y="0"/>
-          <a:chExt cx="0" cy="0"/>
-        </a:xfrm>
-      </p:grpSpPr>
-      <p:sp>
-        <p:nvSpPr>
-          <p:cNvPr id="2" name="Title 1">
-            <a:extLst>
-              <a:ext uri="{FF2B5EF4-FFF2-40B4-BE49-F238E27FC236}">
-                <a16:creationId xmlns:a16="http://schemas.microsoft.com/office/drawing/2014/main" id="{B0117384-56C5-24B5-624E-767F3168840B}"/>
-              </a:ext>
-            </a:extLst>
-          </p:cNvPr>
-          <p:cNvSpPr>
-            <a:spLocks noGrp="1"/>
-          </p:cNvSpPr>
-          <p:nvPr>
-            <p:ph type="title"/>
-          </p:nvPr>
-        </p:nvSpPr>
-        <p:spPr>
-          <a:xfrm>
-            <a:off x="838200" y="365125"/>
-            <a:ext cx="10515600" cy="640080"/>
-          </a:xfrm>
-        </p:spPr>
-        <p:txBody>
-          <a:bodyPr>
-            <a:normAutofit/>
-          </a:bodyPr>
-          <a:lstStyle/>
-          <a:p>
-            <a:pPr algn="ctr"/>
-            <a:r>
-              <a:rPr lang="en-US" sz="3600" dirty="0">
-                <a:latin typeface="Bebas Neue" panose="020B0606020202050201" pitchFamily="34" charset="0"/>
-              </a:rPr>
-              <a:t>Performance and Limitations </a:t>
-            </a:r>
-          </a:p>
-        </p:txBody>
-      </p:sp>
-      <p:sp>
-        <p:nvSpPr>
-          <p:cNvPr id="3" name="Content Placeholder 2">
-            <a:extLst>
-              <a:ext uri="{FF2B5EF4-FFF2-40B4-BE49-F238E27FC236}">
-                <a16:creationId xmlns:a16="http://schemas.microsoft.com/office/drawing/2014/main" id="{F56ACDEB-9BE6-9E8C-F3F3-47CC1816FE9C}"/>
-              </a:ext>
-            </a:extLst>
-          </p:cNvPr>
-          <p:cNvSpPr>
-            <a:spLocks noGrp="1"/>
-          </p:cNvSpPr>
-          <p:nvPr>
-            <p:ph idx="1"/>
-          </p:nvPr>
-        </p:nvSpPr>
-        <p:spPr>
-          <a:xfrm>
-            <a:off x="838200" y="1091381"/>
-            <a:ext cx="10515600" cy="5085582"/>
-          </a:xfrm>
-        </p:spPr>
-        <p:txBody>
-          <a:bodyPr>
-            <a:normAutofit/>
-          </a:bodyPr>
-          <a:lstStyle/>
-          <a:p>
-            <a:pPr marL="0" indent="0">
-              <a:buNone/>
-            </a:pPr>
-            <a:r>
-              <a:rPr lang="en-US" sz="2400" dirty="0">
-                <a:latin typeface="Open Sans" pitchFamily="2" charset="0"/>
-                <a:ea typeface="Open Sans" pitchFamily="2" charset="0"/>
-                <a:cs typeface="Open Sans" pitchFamily="2" charset="0"/>
-              </a:rPr>
-              <a:t>Label encoding is computationally efficient. Both </a:t>
-            </a:r>
-            <a:r>
-              <a:rPr lang="en-US" sz="2400" dirty="0" err="1">
-                <a:latin typeface="Open Sans" pitchFamily="2" charset="0"/>
-                <a:ea typeface="Open Sans" pitchFamily="2" charset="0"/>
-                <a:cs typeface="Open Sans" pitchFamily="2" charset="0"/>
-              </a:rPr>
-              <a:t>LabelEncoder</a:t>
-            </a:r>
-            <a:r>
-              <a:rPr lang="en-US" sz="2400" dirty="0">
-                <a:latin typeface="Open Sans" pitchFamily="2" charset="0"/>
-                <a:ea typeface="Open Sans" pitchFamily="2" charset="0"/>
-                <a:cs typeface="Open Sans" pitchFamily="2" charset="0"/>
-              </a:rPr>
-              <a:t> and pandas' Categorical require a single scan of the data (O(n)) to map categories. Memory usage is minimal as only integer codes and the category map are stored.</a:t>
-            </a:r>
-          </a:p>
-        </p:txBody>
-      </p:sp>
-    </p:spTree>
-    <p:extLst>
-      <p:ext uri="{BB962C8B-B14F-4D97-AF65-F5344CB8AC3E}">
-        <p14:creationId xmlns:p14="http://schemas.microsoft.com/office/powerpoint/2010/main" val="2707570697"/>
-      </p:ext>
-    </p:extLst>
-  </p:cSld>
-  <p:clrMapOvr>
-    <a:masterClrMapping/>
-  </p:clrMapOvr>
-</p:sld>
-</file>
-
 <file path=ppt/slides/slide7.xml><?xml version="1.0" encoding="utf-8"?>
 <p:sld xmlns:a="http://schemas.openxmlformats.org/drawingml/2006/main" xmlns:r="http://schemas.openxmlformats.org/officeDocument/2006/relationships" xmlns:p="http://schemas.openxmlformats.org/presentationml/2006/main">
   <p:cSld>
@@ -9134,7 +9066,7 @@
               <a:rPr lang="en-US" sz="3600" dirty="0">
                 <a:latin typeface="Bebas Neue" panose="020B0606020202050201" pitchFamily="34" charset="0"/>
               </a:rPr>
-              <a:t>Limitations </a:t>
+              <a:t>Performance and Limitations </a:t>
             </a:r>
           </a:p>
         </p:txBody>
@@ -9167,33 +9099,24 @@
           </a:bodyPr>
           <a:lstStyle/>
           <a:p>
-            <a:pPr marL="342900" indent="-342900" fontAlgn="base"/>
-            <a:r>
-              <a:rPr lang="en-US" sz="2400" b="1" dirty="0">
-                <a:latin typeface="Open Sans" pitchFamily="2" charset="0"/>
-                <a:ea typeface="Open Sans" pitchFamily="2" charset="0"/>
-                <a:cs typeface="Open Sans" pitchFamily="2" charset="0"/>
-              </a:rPr>
-              <a:t>Nominal data misinterpretation:</a:t>
-            </a:r>
+            <a:pPr marL="0" indent="0">
+              <a:buNone/>
+            </a:pPr>
             <a:r>
               <a:rPr lang="en-US" sz="2400" dirty="0">
                 <a:latin typeface="Open Sans" pitchFamily="2" charset="0"/>
                 <a:ea typeface="Open Sans" pitchFamily="2" charset="0"/>
                 <a:cs typeface="Open Sans" pitchFamily="2" charset="0"/>
               </a:rPr>
-              <a:t> Encoded integers can imply false order; one-hot encoding is safer for nominal features.</a:t>
-            </a:r>
-          </a:p>
-          <a:p>
-            <a:pPr marL="342900" indent="-342900" fontAlgn="base"/>
-            <a:r>
-              <a:rPr lang="en-US" sz="2400" b="1" dirty="0">
+              <a:t>Label encoding is computationally efficient. Both </a:t>
+            </a:r>
+            <a:r>
+              <a:rPr lang="en-US" sz="2400" dirty="0" err="1">
                 <a:latin typeface="Open Sans" pitchFamily="2" charset="0"/>
                 <a:ea typeface="Open Sans" pitchFamily="2" charset="0"/>
                 <a:cs typeface="Open Sans" pitchFamily="2" charset="0"/>
               </a:rPr>
-              <a:t>Missing values:</a:t>
+              <a:t>LabelEncoder</a:t>
             </a:r>
             <a:r>
               <a:rPr lang="en-US" sz="2400" dirty="0">
@@ -9201,45 +9124,7 @@
                 <a:ea typeface="Open Sans" pitchFamily="2" charset="0"/>
                 <a:cs typeface="Open Sans" pitchFamily="2" charset="0"/>
               </a:rPr>
-              <a:t> These must be handled prior to encoding.</a:t>
-            </a:r>
-          </a:p>
-          <a:p>
-            <a:pPr marL="342900" indent="-342900" fontAlgn="base"/>
-            <a:r>
-              <a:rPr lang="en-US" sz="2400" b="1" dirty="0">
-                <a:latin typeface="Open Sans" pitchFamily="2" charset="0"/>
-                <a:ea typeface="Open Sans" pitchFamily="2" charset="0"/>
-                <a:cs typeface="Open Sans" pitchFamily="2" charset="0"/>
-              </a:rPr>
-              <a:t>Unseen categories in test data:</a:t>
-            </a:r>
-            <a:r>
-              <a:rPr lang="en-US" sz="2400" dirty="0">
-                <a:latin typeface="Open Sans" pitchFamily="2" charset="0"/>
-                <a:ea typeface="Open Sans" pitchFamily="2" charset="0"/>
-                <a:cs typeface="Open Sans" pitchFamily="2" charset="0"/>
-              </a:rPr>
-              <a:t> Encoders will fail if new categories appear; handle this with a default value or ensure training includes all possible categories.</a:t>
-            </a:r>
-          </a:p>
-          <a:p>
-            <a:pPr marL="342900" indent="-342900" fontAlgn="base"/>
-            <a:r>
-              <a:rPr lang="en-US" sz="2400" b="1" dirty="0">
-                <a:latin typeface="Open Sans" pitchFamily="2" charset="0"/>
-                <a:ea typeface="Open Sans" pitchFamily="2" charset="0"/>
-                <a:cs typeface="Open Sans" pitchFamily="2" charset="0"/>
-              </a:rPr>
-              <a:t>High cardinality:</a:t>
-            </a:r>
-            <a:r>
-              <a:rPr lang="en-US" sz="2400" dirty="0">
-                <a:latin typeface="Open Sans" pitchFamily="2" charset="0"/>
-                <a:ea typeface="Open Sans" pitchFamily="2" charset="0"/>
-                <a:cs typeface="Open Sans" pitchFamily="2" charset="0"/>
-              </a:rPr>
-              <a:t> Features with many unique categories may still require additional feature engineering.</a:t>
+              <a:t> and pandas' Categorical require a single scan of the data (O(n)) to map categories. Memory usage is minimal as only integer codes and the category map are stored.</a:t>
             </a:r>
           </a:p>
         </p:txBody>
@@ -9247,7 +9132,7 @@
     </p:spTree>
     <p:extLst>
       <p:ext uri="{BB962C8B-B14F-4D97-AF65-F5344CB8AC3E}">
-        <p14:creationId xmlns:p14="http://schemas.microsoft.com/office/powerpoint/2010/main" val="299826593"/>
+        <p14:creationId xmlns:p14="http://schemas.microsoft.com/office/powerpoint/2010/main" val="2707570697"/>
       </p:ext>
     </p:extLst>
   </p:cSld>
@@ -9313,7 +9198,7 @@
               <a:rPr lang="en-US" sz="3600" dirty="0">
                 <a:latin typeface="Bebas Neue" panose="020B0606020202050201" pitchFamily="34" charset="0"/>
               </a:rPr>
-              <a:t>Best Practices </a:t>
+              <a:t>Limitations </a:t>
             </a:r>
           </a:p>
         </p:txBody>
@@ -9348,45 +9233,77 @@
           <a:p>
             <a:pPr marL="342900" indent="-342900" fontAlgn="base"/>
             <a:r>
+              <a:rPr lang="en-US" sz="2400" b="1" dirty="0">
+                <a:latin typeface="Open Sans" pitchFamily="2" charset="0"/>
+                <a:ea typeface="Open Sans" pitchFamily="2" charset="0"/>
+                <a:cs typeface="Open Sans" pitchFamily="2" charset="0"/>
+              </a:rPr>
+              <a:t>Nominal data misinterpretation:</a:t>
+            </a:r>
+            <a:r>
               <a:rPr lang="en-US" sz="2400" dirty="0">
                 <a:latin typeface="Open Sans" pitchFamily="2" charset="0"/>
                 <a:ea typeface="Open Sans" pitchFamily="2" charset="0"/>
                 <a:cs typeface="Open Sans" pitchFamily="2" charset="0"/>
               </a:rPr>
-              <a:t>Apply label encoding primarily to ordinal features or tree-based models.</a:t>
+              <a:t> Encoded integers can imply false order; one-hot encoding is safer for nominal features.</a:t>
             </a:r>
           </a:p>
           <a:p>
             <a:pPr marL="342900" indent="-342900" fontAlgn="base"/>
+            <a:r>
+              <a:rPr lang="en-US" sz="2400" b="1" dirty="0">
+                <a:latin typeface="Open Sans" pitchFamily="2" charset="0"/>
+                <a:ea typeface="Open Sans" pitchFamily="2" charset="0"/>
+                <a:cs typeface="Open Sans" pitchFamily="2" charset="0"/>
+              </a:rPr>
+              <a:t>Missing values:</a:t>
+            </a:r>
             <a:r>
               <a:rPr lang="en-US" sz="2400" dirty="0">
                 <a:latin typeface="Open Sans" pitchFamily="2" charset="0"/>
                 <a:ea typeface="Open Sans" pitchFamily="2" charset="0"/>
                 <a:cs typeface="Open Sans" pitchFamily="2" charset="0"/>
               </a:rPr>
-              <a:t>Handle missing values before encoding.</a:t>
+              <a:t> These must be handled prior to encoding.</a:t>
             </a:r>
           </a:p>
           <a:p>
             <a:pPr marL="342900" indent="-342900" fontAlgn="base"/>
+            <a:r>
+              <a:rPr lang="en-US" sz="2400" b="1" dirty="0">
+                <a:latin typeface="Open Sans" pitchFamily="2" charset="0"/>
+                <a:ea typeface="Open Sans" pitchFamily="2" charset="0"/>
+                <a:cs typeface="Open Sans" pitchFamily="2" charset="0"/>
+              </a:rPr>
+              <a:t>Unseen categories in test data:</a:t>
+            </a:r>
             <a:r>
               <a:rPr lang="en-US" sz="2400" dirty="0">
                 <a:latin typeface="Open Sans" pitchFamily="2" charset="0"/>
                 <a:ea typeface="Open Sans" pitchFamily="2" charset="0"/>
                 <a:cs typeface="Open Sans" pitchFamily="2" charset="0"/>
               </a:rPr>
-              <a:t>Save the encoder or category mapping to enable inverse transformation during evaluation or deployment.</a:t>
+              <a:t> Encoders will fail if new categories appear; handle this with a default value or ensure training includes all possible categories.</a:t>
             </a:r>
           </a:p>
           <a:p>
             <a:pPr marL="342900" indent="-342900" fontAlgn="base"/>
+            <a:r>
+              <a:rPr lang="en-US" sz="2400" b="1" dirty="0">
+                <a:latin typeface="Open Sans" pitchFamily="2" charset="0"/>
+                <a:ea typeface="Open Sans" pitchFamily="2" charset="0"/>
+                <a:cs typeface="Open Sans" pitchFamily="2" charset="0"/>
+              </a:rPr>
+              <a:t>High cardinality:</a:t>
+            </a:r>
             <a:r>
               <a:rPr lang="en-US" sz="2400" dirty="0">
                 <a:latin typeface="Open Sans" pitchFamily="2" charset="0"/>
                 <a:ea typeface="Open Sans" pitchFamily="2" charset="0"/>
                 <a:cs typeface="Open Sans" pitchFamily="2" charset="0"/>
               </a:rPr>
-              <a:t>For nominal features in algorithms sensitive to numerical relationships, use one-hot encoding instead.</a:t>
+              <a:t> Features with many unique categories may still require additional feature engineering.</a:t>
             </a:r>
           </a:p>
         </p:txBody>
@@ -9394,7 +9311,7 @@
     </p:spTree>
     <p:extLst>
       <p:ext uri="{BB962C8B-B14F-4D97-AF65-F5344CB8AC3E}">
-        <p14:creationId xmlns:p14="http://schemas.microsoft.com/office/powerpoint/2010/main" val="3192306864"/>
+        <p14:creationId xmlns:p14="http://schemas.microsoft.com/office/powerpoint/2010/main" val="299826593"/>
       </p:ext>
     </p:extLst>
   </p:cSld>
@@ -9460,9 +9377,8 @@
               <a:rPr lang="en-US" sz="3600" dirty="0">
                 <a:latin typeface="Bebas Neue" panose="020B0606020202050201" pitchFamily="34" charset="0"/>
               </a:rPr>
-              <a:t>T</a:t>
-            </a:r>
-            <a:endParaRPr lang="en-US" sz="3600" dirty="0"/>
+              <a:t>Best Practices </a:t>
+            </a:r>
           </a:p>
         </p:txBody>
       </p:sp>
@@ -9494,16 +9410,47 @@
           </a:bodyPr>
           <a:lstStyle/>
           <a:p>
-            <a:pPr marL="0" indent="0" algn="just">
-              <a:buNone/>
-            </a:pPr>
+            <a:pPr marL="342900" indent="-342900" fontAlgn="base"/>
             <a:r>
               <a:rPr lang="en-US" sz="2400" dirty="0">
                 <a:latin typeface="Open Sans" pitchFamily="2" charset="0"/>
                 <a:ea typeface="Open Sans" pitchFamily="2" charset="0"/>
                 <a:cs typeface="Open Sans" pitchFamily="2" charset="0"/>
               </a:rPr>
-              <a:t>H</a:t>
+              <a:t>Apply label encoding primarily to ordinal features or tree-based models.</a:t>
+            </a:r>
+          </a:p>
+          <a:p>
+            <a:pPr marL="342900" indent="-342900" fontAlgn="base"/>
+            <a:r>
+              <a:rPr lang="en-US" sz="2400" dirty="0">
+                <a:latin typeface="Open Sans" pitchFamily="2" charset="0"/>
+                <a:ea typeface="Open Sans" pitchFamily="2" charset="0"/>
+                <a:cs typeface="Open Sans" pitchFamily="2" charset="0"/>
+              </a:rPr>
+              <a:t>Handle missing values before encoding.</a:t>
+            </a:r>
+          </a:p>
+          <a:p>
+            <a:pPr marL="342900" indent="-342900" fontAlgn="base"/>
+            <a:r>
+              <a:rPr lang="en-US" sz="2400" dirty="0">
+                <a:latin typeface="Open Sans" pitchFamily="2" charset="0"/>
+                <a:ea typeface="Open Sans" pitchFamily="2" charset="0"/>
+                <a:cs typeface="Open Sans" pitchFamily="2" charset="0"/>
+              </a:rPr>
+              <a:t>Save the encoder or category mapping to enable inverse transformation during evaluation or deployment.</a:t>
+            </a:r>
+          </a:p>
+          <a:p>
+            <a:pPr marL="342900" indent="-342900" fontAlgn="base"/>
+            <a:r>
+              <a:rPr lang="en-US" sz="2400" dirty="0">
+                <a:latin typeface="Open Sans" pitchFamily="2" charset="0"/>
+                <a:ea typeface="Open Sans" pitchFamily="2" charset="0"/>
+                <a:cs typeface="Open Sans" pitchFamily="2" charset="0"/>
+              </a:rPr>
+              <a:t>For nominal features in algorithms sensitive to numerical relationships, use one-hot encoding instead.</a:t>
             </a:r>
           </a:p>
         </p:txBody>
@@ -9511,7 +9458,7 @@
     </p:spTree>
     <p:extLst>
       <p:ext uri="{BB962C8B-B14F-4D97-AF65-F5344CB8AC3E}">
-        <p14:creationId xmlns:p14="http://schemas.microsoft.com/office/powerpoint/2010/main" val="3297150731"/>
+        <p14:creationId xmlns:p14="http://schemas.microsoft.com/office/powerpoint/2010/main" val="3192306864"/>
       </p:ext>
     </p:extLst>
   </p:cSld>

</xml_diff>